<commit_message>
Week 8 Slide Updates
</commit_message>
<xml_diff>
--- a/Weekly Reports/slides/4-abigail-duran.pptx
+++ b/Weekly Reports/slides/4-abigail-duran.pptx
@@ -7,6 +7,8 @@
   <p:sldIdLst>
     <p:sldId id="257" r:id="rId2"/>
     <p:sldId id="258" r:id="rId3"/>
+    <p:sldId id="259" r:id="rId4"/>
+    <p:sldId id="260" r:id="rId5"/>
   </p:sldIdLst>
   <p:sldSz cx="12192000" cy="6858000"/>
   <p:notesSz cx="6858000" cy="9144000"/>
@@ -260,7 +262,7 @@
           <a:p>
             <a:fld id="{752E6B35-DAD5-CF47-9E65-9CA12B499D8C}" type="datetimeFigureOut">
               <a:rPr lang="en-US" smtClean="0"/>
-              <a:t>10/6/26</a:t>
+              <a:t>10/12/26</a:t>
             </a:fld>
             <a:endParaRPr lang="en-US"/>
           </a:p>
@@ -458,7 +460,7 @@
           <a:p>
             <a:fld id="{752E6B35-DAD5-CF47-9E65-9CA12B499D8C}" type="datetimeFigureOut">
               <a:rPr lang="en-US" smtClean="0"/>
-              <a:t>10/6/26</a:t>
+              <a:t>10/12/26</a:t>
             </a:fld>
             <a:endParaRPr lang="en-US"/>
           </a:p>
@@ -666,7 +668,7 @@
           <a:p>
             <a:fld id="{752E6B35-DAD5-CF47-9E65-9CA12B499D8C}" type="datetimeFigureOut">
               <a:rPr lang="en-US" smtClean="0"/>
-              <a:t>10/6/26</a:t>
+              <a:t>10/12/26</a:t>
             </a:fld>
             <a:endParaRPr lang="en-US"/>
           </a:p>
@@ -864,7 +866,7 @@
           <a:p>
             <a:fld id="{752E6B35-DAD5-CF47-9E65-9CA12B499D8C}" type="datetimeFigureOut">
               <a:rPr lang="en-US" smtClean="0"/>
-              <a:t>10/6/26</a:t>
+              <a:t>10/12/26</a:t>
             </a:fld>
             <a:endParaRPr lang="en-US"/>
           </a:p>
@@ -1139,7 +1141,7 @@
           <a:p>
             <a:fld id="{752E6B35-DAD5-CF47-9E65-9CA12B499D8C}" type="datetimeFigureOut">
               <a:rPr lang="en-US" smtClean="0"/>
-              <a:t>10/6/26</a:t>
+              <a:t>10/12/26</a:t>
             </a:fld>
             <a:endParaRPr lang="en-US"/>
           </a:p>
@@ -1404,7 +1406,7 @@
           <a:p>
             <a:fld id="{752E6B35-DAD5-CF47-9E65-9CA12B499D8C}" type="datetimeFigureOut">
               <a:rPr lang="en-US" smtClean="0"/>
-              <a:t>10/6/26</a:t>
+              <a:t>10/12/26</a:t>
             </a:fld>
             <a:endParaRPr lang="en-US"/>
           </a:p>
@@ -1816,7 +1818,7 @@
           <a:p>
             <a:fld id="{752E6B35-DAD5-CF47-9E65-9CA12B499D8C}" type="datetimeFigureOut">
               <a:rPr lang="en-US" smtClean="0"/>
-              <a:t>10/6/26</a:t>
+              <a:t>10/12/26</a:t>
             </a:fld>
             <a:endParaRPr lang="en-US"/>
           </a:p>
@@ -1957,7 +1959,7 @@
           <a:p>
             <a:fld id="{752E6B35-DAD5-CF47-9E65-9CA12B499D8C}" type="datetimeFigureOut">
               <a:rPr lang="en-US" smtClean="0"/>
-              <a:t>10/6/26</a:t>
+              <a:t>10/12/26</a:t>
             </a:fld>
             <a:endParaRPr lang="en-US"/>
           </a:p>
@@ -2070,7 +2072,7 @@
           <a:p>
             <a:fld id="{752E6B35-DAD5-CF47-9E65-9CA12B499D8C}" type="datetimeFigureOut">
               <a:rPr lang="en-US" smtClean="0"/>
-              <a:t>10/6/26</a:t>
+              <a:t>10/12/26</a:t>
             </a:fld>
             <a:endParaRPr lang="en-US"/>
           </a:p>
@@ -2381,7 +2383,7 @@
           <a:p>
             <a:fld id="{752E6B35-DAD5-CF47-9E65-9CA12B499D8C}" type="datetimeFigureOut">
               <a:rPr lang="en-US" smtClean="0"/>
-              <a:t>10/6/26</a:t>
+              <a:t>10/12/26</a:t>
             </a:fld>
             <a:endParaRPr lang="en-US"/>
           </a:p>
@@ -2669,7 +2671,7 @@
           <a:p>
             <a:fld id="{752E6B35-DAD5-CF47-9E65-9CA12B499D8C}" type="datetimeFigureOut">
               <a:rPr lang="en-US" smtClean="0"/>
-              <a:t>10/6/26</a:t>
+              <a:t>10/12/26</a:t>
             </a:fld>
             <a:endParaRPr lang="en-US"/>
           </a:p>
@@ -2910,7 +2912,7 @@
           <a:p>
             <a:fld id="{752E6B35-DAD5-CF47-9E65-9CA12B499D8C}" type="datetimeFigureOut">
               <a:rPr lang="en-US" smtClean="0"/>
-              <a:t>10/6/26</a:t>
+              <a:t>10/12/26</a:t>
             </a:fld>
             <a:endParaRPr lang="en-US"/>
           </a:p>
@@ -3378,7 +3380,7 @@
         </p:spPr>
         <p:txBody>
           <a:bodyPr>
-            <a:normAutofit fontScale="85000" lnSpcReduction="20000"/>
+            <a:normAutofit fontScale="70000" lnSpcReduction="20000"/>
           </a:bodyPr>
           <a:lstStyle/>
           <a:p>
@@ -3392,14 +3394,22 @@
             <a:pPr lvl="1"/>
             <a:r>
               <a:rPr lang="en-US" dirty="0"/>
-              <a:t>Finalize the list of components and connections that will be included on the final PCB.</a:t>
+              <a:t>Prepare the PCB design files with all currently selected components and required connections.</a:t>
             </a:r>
           </a:p>
           <a:p>
             <a:pPr lvl="1"/>
             <a:r>
               <a:rPr lang="en-US" dirty="0"/>
-              <a:t>Identify what parts of the CM5 IO board are necessary for the project.</a:t>
+              <a:t>Make sure the schematic reflects the components planned for the current </a:t>
+            </a:r>
+            <a:r>
+              <a:rPr lang="en-US" dirty="0" err="1"/>
+              <a:t>BuggyBot</a:t>
+            </a:r>
+            <a:r>
+              <a:rPr lang="en-US" dirty="0"/>
+              <a:t> hardware setup.</a:t>
             </a:r>
           </a:p>
           <a:p>
@@ -3426,7 +3436,7 @@
             <a:pPr lvl="1"/>
             <a:r>
               <a:rPr lang="en-US" dirty="0"/>
-              <a:t>Narrowed down the components needed for the final custom PCB.</a:t>
+              <a:t>Removed unnecessary components from both the schematic and PCB layout.</a:t>
             </a:r>
           </a:p>
           <a:p>
@@ -3443,7 +3453,7 @@
             <a:pPr lvl="1"/>
             <a:r>
               <a:rPr lang="en-US" dirty="0"/>
-              <a:t>Begin planning the PCB layout, including component placement and board dimensions.​</a:t>
+              <a:t>Continue developing the PCB design and component placement.</a:t>
             </a:r>
           </a:p>
           <a:p>
@@ -3457,7 +3467,7 @@
             <a:pPr lvl="1"/>
             <a:r>
               <a:rPr lang="en-US" dirty="0"/>
-              <a:t>Start transferring the finalized component requirements into the PCB design.</a:t>
+              <a:t>Work toward finalizing the PCB design for manufacturing.</a:t>
             </a:r>
             <a:endParaRPr dirty="0"/>
           </a:p>
@@ -3675,10 +3685,10 @@
       </p:sp>
       <p:pic>
         <p:nvPicPr>
-          <p:cNvPr id="7" name="Picture 6">
-            <a:extLst>
-              <a:ext uri="{FF2B5EF4-FFF2-40B4-BE49-F238E27FC236}">
-                <a16:creationId xmlns:a16="http://schemas.microsoft.com/office/drawing/2014/main" id="{6A847D18-1A87-FA4C-7DFB-55209922AE72}"/>
+          <p:cNvPr id="3" name="Picture 2">
+            <a:extLst>
+              <a:ext uri="{FF2B5EF4-FFF2-40B4-BE49-F238E27FC236}">
+                <a16:creationId xmlns:a16="http://schemas.microsoft.com/office/drawing/2014/main" id="{10F150F6-B5DC-9B0E-7802-A8FC01B0B8C8}"/>
               </a:ext>
             </a:extLst>
           </p:cNvPr>
@@ -3695,8 +3705,8 @@
         </p:blipFill>
         <p:spPr>
           <a:xfrm>
-            <a:off x="774756" y="452384"/>
-            <a:ext cx="10642488" cy="5953232"/>
+            <a:off x="1377950" y="368556"/>
+            <a:ext cx="9436100" cy="6120887"/>
           </a:xfrm>
           <a:prstGeom prst="rect">
             <a:avLst/>
@@ -3707,6 +3717,126 @@
     <p:extLst>
       <p:ext uri="{BB962C8B-B14F-4D97-AF65-F5344CB8AC3E}">
         <p14:creationId xmlns:p14="http://schemas.microsoft.com/office/powerpoint/2010/main" val="440385375"/>
+      </p:ext>
+    </p:extLst>
+  </p:cSld>
+  <p:clrMapOvr>
+    <a:masterClrMapping/>
+  </p:clrMapOvr>
+</p:sld>
+</file>
+
+<file path=ppt/slides/slide3.xml><?xml version="1.0" encoding="utf-8"?>
+<p:sld xmlns:a="http://schemas.openxmlformats.org/drawingml/2006/main" xmlns:r="http://schemas.openxmlformats.org/officeDocument/2006/relationships" xmlns:p="http://schemas.openxmlformats.org/presentationml/2006/main">
+  <p:cSld>
+    <p:spTree>
+      <p:nvGrpSpPr>
+        <p:cNvPr id="1" name=""/>
+        <p:cNvGrpSpPr/>
+        <p:nvPr/>
+      </p:nvGrpSpPr>
+      <p:grpSpPr>
+        <a:xfrm>
+          <a:off x="0" y="0"/>
+          <a:ext cx="0" cy="0"/>
+          <a:chOff x="0" y="0"/>
+          <a:chExt cx="0" cy="0"/>
+        </a:xfrm>
+      </p:grpSpPr>
+      <p:pic>
+        <p:nvPicPr>
+          <p:cNvPr id="5" name="Picture 4">
+            <a:extLst>
+              <a:ext uri="{FF2B5EF4-FFF2-40B4-BE49-F238E27FC236}">
+                <a16:creationId xmlns:a16="http://schemas.microsoft.com/office/drawing/2014/main" id="{34186BFD-4D32-6F06-6690-29A945916E9F}"/>
+              </a:ext>
+            </a:extLst>
+          </p:cNvPr>
+          <p:cNvPicPr>
+            <a:picLocks noChangeAspect="1"/>
+          </p:cNvPicPr>
+          <p:nvPr/>
+        </p:nvPicPr>
+        <p:blipFill>
+          <a:blip r:embed="rId2"/>
+          <a:stretch>
+            <a:fillRect/>
+          </a:stretch>
+        </p:blipFill>
+        <p:spPr>
+          <a:xfrm>
+            <a:off x="1355725" y="700902"/>
+            <a:ext cx="9480550" cy="5456196"/>
+          </a:xfrm>
+          <a:prstGeom prst="rect">
+            <a:avLst/>
+          </a:prstGeom>
+        </p:spPr>
+      </p:pic>
+    </p:spTree>
+    <p:extLst>
+      <p:ext uri="{BB962C8B-B14F-4D97-AF65-F5344CB8AC3E}">
+        <p14:creationId xmlns:p14="http://schemas.microsoft.com/office/powerpoint/2010/main" val="1264065741"/>
+      </p:ext>
+    </p:extLst>
+  </p:cSld>
+  <p:clrMapOvr>
+    <a:masterClrMapping/>
+  </p:clrMapOvr>
+</p:sld>
+</file>
+
+<file path=ppt/slides/slide4.xml><?xml version="1.0" encoding="utf-8"?>
+<p:sld xmlns:a="http://schemas.openxmlformats.org/drawingml/2006/main" xmlns:r="http://schemas.openxmlformats.org/officeDocument/2006/relationships" xmlns:p="http://schemas.openxmlformats.org/presentationml/2006/main">
+  <p:cSld>
+    <p:spTree>
+      <p:nvGrpSpPr>
+        <p:cNvPr id="1" name=""/>
+        <p:cNvGrpSpPr/>
+        <p:nvPr/>
+      </p:nvGrpSpPr>
+      <p:grpSpPr>
+        <a:xfrm>
+          <a:off x="0" y="0"/>
+          <a:ext cx="0" cy="0"/>
+          <a:chOff x="0" y="0"/>
+          <a:chExt cx="0" cy="0"/>
+        </a:xfrm>
+      </p:grpSpPr>
+      <p:pic>
+        <p:nvPicPr>
+          <p:cNvPr id="3" name="Picture 2">
+            <a:extLst>
+              <a:ext uri="{FF2B5EF4-FFF2-40B4-BE49-F238E27FC236}">
+                <a16:creationId xmlns:a16="http://schemas.microsoft.com/office/drawing/2014/main" id="{A0E52E99-419F-5F59-B3FB-9FE958F8A333}"/>
+              </a:ext>
+            </a:extLst>
+          </p:cNvPr>
+          <p:cNvPicPr>
+            <a:picLocks noChangeAspect="1"/>
+          </p:cNvPicPr>
+          <p:nvPr/>
+        </p:nvPicPr>
+        <p:blipFill>
+          <a:blip r:embed="rId2"/>
+          <a:stretch>
+            <a:fillRect/>
+          </a:stretch>
+        </p:blipFill>
+        <p:spPr>
+          <a:xfrm>
+            <a:off x="1619250" y="831017"/>
+            <a:ext cx="8953500" cy="5195966"/>
+          </a:xfrm>
+          <a:prstGeom prst="rect">
+            <a:avLst/>
+          </a:prstGeom>
+        </p:spPr>
+      </p:pic>
+    </p:spTree>
+    <p:extLst>
+      <p:ext uri="{BB962C8B-B14F-4D97-AF65-F5344CB8AC3E}">
+        <p14:creationId xmlns:p14="http://schemas.microsoft.com/office/powerpoint/2010/main" val="3103841934"/>
       </p:ext>
     </p:extLst>
   </p:cSld>

</xml_diff>

<commit_message>
Week 9 Slide Updates
</commit_message>
<xml_diff>
--- a/Weekly Reports/slides/4-abigail-duran.pptx
+++ b/Weekly Reports/slides/4-abigail-duran.pptx
@@ -6,9 +6,8 @@
   </p:sldMasterIdLst>
   <p:sldIdLst>
     <p:sldId id="257" r:id="rId2"/>
-    <p:sldId id="258" r:id="rId3"/>
-    <p:sldId id="259" r:id="rId4"/>
-    <p:sldId id="260" r:id="rId5"/>
+    <p:sldId id="259" r:id="rId3"/>
+    <p:sldId id="258" r:id="rId4"/>
   </p:sldIdLst>
   <p:sldSz cx="12192000" cy="6858000"/>
   <p:notesSz cx="6858000" cy="9144000"/>
@@ -262,7 +261,7 @@
           <a:p>
             <a:fld id="{752E6B35-DAD5-CF47-9E65-9CA12B499D8C}" type="datetimeFigureOut">
               <a:rPr lang="en-US" smtClean="0"/>
-              <a:t>10/12/26</a:t>
+              <a:t>10/19/26</a:t>
             </a:fld>
             <a:endParaRPr lang="en-US"/>
           </a:p>
@@ -460,7 +459,7 @@
           <a:p>
             <a:fld id="{752E6B35-DAD5-CF47-9E65-9CA12B499D8C}" type="datetimeFigureOut">
               <a:rPr lang="en-US" smtClean="0"/>
-              <a:t>10/12/26</a:t>
+              <a:t>10/19/26</a:t>
             </a:fld>
             <a:endParaRPr lang="en-US"/>
           </a:p>
@@ -668,7 +667,7 @@
           <a:p>
             <a:fld id="{752E6B35-DAD5-CF47-9E65-9CA12B499D8C}" type="datetimeFigureOut">
               <a:rPr lang="en-US" smtClean="0"/>
-              <a:t>10/12/26</a:t>
+              <a:t>10/19/26</a:t>
             </a:fld>
             <a:endParaRPr lang="en-US"/>
           </a:p>
@@ -866,7 +865,7 @@
           <a:p>
             <a:fld id="{752E6B35-DAD5-CF47-9E65-9CA12B499D8C}" type="datetimeFigureOut">
               <a:rPr lang="en-US" smtClean="0"/>
-              <a:t>10/12/26</a:t>
+              <a:t>10/19/26</a:t>
             </a:fld>
             <a:endParaRPr lang="en-US"/>
           </a:p>
@@ -1141,7 +1140,7 @@
           <a:p>
             <a:fld id="{752E6B35-DAD5-CF47-9E65-9CA12B499D8C}" type="datetimeFigureOut">
               <a:rPr lang="en-US" smtClean="0"/>
-              <a:t>10/12/26</a:t>
+              <a:t>10/19/26</a:t>
             </a:fld>
             <a:endParaRPr lang="en-US"/>
           </a:p>
@@ -1406,7 +1405,7 @@
           <a:p>
             <a:fld id="{752E6B35-DAD5-CF47-9E65-9CA12B499D8C}" type="datetimeFigureOut">
               <a:rPr lang="en-US" smtClean="0"/>
-              <a:t>10/12/26</a:t>
+              <a:t>10/19/26</a:t>
             </a:fld>
             <a:endParaRPr lang="en-US"/>
           </a:p>
@@ -1818,7 +1817,7 @@
           <a:p>
             <a:fld id="{752E6B35-DAD5-CF47-9E65-9CA12B499D8C}" type="datetimeFigureOut">
               <a:rPr lang="en-US" smtClean="0"/>
-              <a:t>10/12/26</a:t>
+              <a:t>10/19/26</a:t>
             </a:fld>
             <a:endParaRPr lang="en-US"/>
           </a:p>
@@ -1959,7 +1958,7 @@
           <a:p>
             <a:fld id="{752E6B35-DAD5-CF47-9E65-9CA12B499D8C}" type="datetimeFigureOut">
               <a:rPr lang="en-US" smtClean="0"/>
-              <a:t>10/12/26</a:t>
+              <a:t>10/19/26</a:t>
             </a:fld>
             <a:endParaRPr lang="en-US"/>
           </a:p>
@@ -2072,7 +2071,7 @@
           <a:p>
             <a:fld id="{752E6B35-DAD5-CF47-9E65-9CA12B499D8C}" type="datetimeFigureOut">
               <a:rPr lang="en-US" smtClean="0"/>
-              <a:t>10/12/26</a:t>
+              <a:t>10/19/26</a:t>
             </a:fld>
             <a:endParaRPr lang="en-US"/>
           </a:p>
@@ -2383,7 +2382,7 @@
           <a:p>
             <a:fld id="{752E6B35-DAD5-CF47-9E65-9CA12B499D8C}" type="datetimeFigureOut">
               <a:rPr lang="en-US" smtClean="0"/>
-              <a:t>10/12/26</a:t>
+              <a:t>10/19/26</a:t>
             </a:fld>
             <a:endParaRPr lang="en-US"/>
           </a:p>
@@ -2671,7 +2670,7 @@
           <a:p>
             <a:fld id="{752E6B35-DAD5-CF47-9E65-9CA12B499D8C}" type="datetimeFigureOut">
               <a:rPr lang="en-US" smtClean="0"/>
-              <a:t>10/12/26</a:t>
+              <a:t>10/19/26</a:t>
             </a:fld>
             <a:endParaRPr lang="en-US"/>
           </a:p>
@@ -2912,7 +2911,7 @@
           <a:p>
             <a:fld id="{752E6B35-DAD5-CF47-9E65-9CA12B499D8C}" type="datetimeFigureOut">
               <a:rPr lang="en-US" smtClean="0"/>
-              <a:t>10/12/26</a:t>
+              <a:t>10/19/26</a:t>
             </a:fld>
             <a:endParaRPr lang="en-US"/>
           </a:p>
@@ -3380,7 +3379,7 @@
         </p:spPr>
         <p:txBody>
           <a:bodyPr>
-            <a:normAutofit fontScale="70000" lnSpcReduction="20000"/>
+            <a:normAutofit fontScale="77500" lnSpcReduction="20000"/>
           </a:bodyPr>
           <a:lstStyle/>
           <a:p>
@@ -3436,7 +3435,7 @@
             <a:pPr lvl="1"/>
             <a:r>
               <a:rPr lang="en-US" dirty="0"/>
-              <a:t>Removed unnecessary components from both the schematic and PCB layout.</a:t>
+              <a:t>Added IMU and LCD connectors on the board.</a:t>
             </a:r>
           </a:p>
           <a:p>
@@ -3454,13 +3453,6 @@
             <a:r>
               <a:rPr lang="en-US" dirty="0"/>
               <a:t>Continue developing the PCB design and component placement.</a:t>
-            </a:r>
-          </a:p>
-          <a:p>
-            <a:pPr lvl="1"/>
-            <a:r>
-              <a:rPr lang="en-US" dirty="0"/>
-              <a:t>Begin planning power distribution and signal routing.​</a:t>
             </a:r>
           </a:p>
           <a:p>
@@ -3504,6 +3496,66 @@
 </file>
 
 <file path=ppt/slides/slide2.xml><?xml version="1.0" encoding="utf-8"?>
+<p:sld xmlns:a="http://schemas.openxmlformats.org/drawingml/2006/main" xmlns:r="http://schemas.openxmlformats.org/officeDocument/2006/relationships" xmlns:p="http://schemas.openxmlformats.org/presentationml/2006/main">
+  <p:cSld>
+    <p:spTree>
+      <p:nvGrpSpPr>
+        <p:cNvPr id="1" name=""/>
+        <p:cNvGrpSpPr/>
+        <p:nvPr/>
+      </p:nvGrpSpPr>
+      <p:grpSpPr>
+        <a:xfrm>
+          <a:off x="0" y="0"/>
+          <a:ext cx="0" cy="0"/>
+          <a:chOff x="0" y="0"/>
+          <a:chExt cx="0" cy="0"/>
+        </a:xfrm>
+      </p:grpSpPr>
+      <p:pic>
+        <p:nvPicPr>
+          <p:cNvPr id="3" name="Picture 2">
+            <a:extLst>
+              <a:ext uri="{FF2B5EF4-FFF2-40B4-BE49-F238E27FC236}">
+                <a16:creationId xmlns:a16="http://schemas.microsoft.com/office/drawing/2014/main" id="{B71870F1-2187-FBD8-D06D-8778AEBE17D5}"/>
+              </a:ext>
+            </a:extLst>
+          </p:cNvPr>
+          <p:cNvPicPr>
+            <a:picLocks noChangeAspect="1"/>
+          </p:cNvPicPr>
+          <p:nvPr/>
+        </p:nvPicPr>
+        <p:blipFill>
+          <a:blip r:embed="rId2"/>
+          <a:stretch>
+            <a:fillRect/>
+          </a:stretch>
+        </p:blipFill>
+        <p:spPr>
+          <a:xfrm>
+            <a:off x="1342371" y="1531408"/>
+            <a:ext cx="9507257" cy="3795183"/>
+          </a:xfrm>
+          <a:prstGeom prst="rect">
+            <a:avLst/>
+          </a:prstGeom>
+        </p:spPr>
+      </p:pic>
+    </p:spTree>
+    <p:extLst>
+      <p:ext uri="{BB962C8B-B14F-4D97-AF65-F5344CB8AC3E}">
+        <p14:creationId xmlns:p14="http://schemas.microsoft.com/office/powerpoint/2010/main" val="1097263825"/>
+      </p:ext>
+    </p:extLst>
+  </p:cSld>
+  <p:clrMapOvr>
+    <a:masterClrMapping/>
+  </p:clrMapOvr>
+</p:sld>
+</file>
+
+<file path=ppt/slides/slide3.xml><?xml version="1.0" encoding="utf-8"?>
 <p:sld xmlns:a="http://schemas.openxmlformats.org/drawingml/2006/main" xmlns:r="http://schemas.openxmlformats.org/officeDocument/2006/relationships" xmlns:p="http://schemas.openxmlformats.org/presentationml/2006/main">
   <p:cSld>
     <p:bg>
@@ -3685,10 +3737,10 @@
       </p:sp>
       <p:pic>
         <p:nvPicPr>
-          <p:cNvPr id="3" name="Picture 2">
-            <a:extLst>
-              <a:ext uri="{FF2B5EF4-FFF2-40B4-BE49-F238E27FC236}">
-                <a16:creationId xmlns:a16="http://schemas.microsoft.com/office/drawing/2014/main" id="{10F150F6-B5DC-9B0E-7802-A8FC01B0B8C8}"/>
+          <p:cNvPr id="4" name="Picture 3">
+            <a:extLst>
+              <a:ext uri="{FF2B5EF4-FFF2-40B4-BE49-F238E27FC236}">
+                <a16:creationId xmlns:a16="http://schemas.microsoft.com/office/drawing/2014/main" id="{2404F76B-D95C-4864-55C7-06717C4B522B}"/>
               </a:ext>
             </a:extLst>
           </p:cNvPr>
@@ -3705,8 +3757,8 @@
         </p:blipFill>
         <p:spPr>
           <a:xfrm>
-            <a:off x="1377950" y="368556"/>
-            <a:ext cx="9436100" cy="6120887"/>
+            <a:off x="1326797" y="451083"/>
+            <a:ext cx="9538406" cy="5955834"/>
           </a:xfrm>
           <a:prstGeom prst="rect">
             <a:avLst/>
@@ -3717,126 +3769,6 @@
     <p:extLst>
       <p:ext uri="{BB962C8B-B14F-4D97-AF65-F5344CB8AC3E}">
         <p14:creationId xmlns:p14="http://schemas.microsoft.com/office/powerpoint/2010/main" val="440385375"/>
-      </p:ext>
-    </p:extLst>
-  </p:cSld>
-  <p:clrMapOvr>
-    <a:masterClrMapping/>
-  </p:clrMapOvr>
-</p:sld>
-</file>
-
-<file path=ppt/slides/slide3.xml><?xml version="1.0" encoding="utf-8"?>
-<p:sld xmlns:a="http://schemas.openxmlformats.org/drawingml/2006/main" xmlns:r="http://schemas.openxmlformats.org/officeDocument/2006/relationships" xmlns:p="http://schemas.openxmlformats.org/presentationml/2006/main">
-  <p:cSld>
-    <p:spTree>
-      <p:nvGrpSpPr>
-        <p:cNvPr id="1" name=""/>
-        <p:cNvGrpSpPr/>
-        <p:nvPr/>
-      </p:nvGrpSpPr>
-      <p:grpSpPr>
-        <a:xfrm>
-          <a:off x="0" y="0"/>
-          <a:ext cx="0" cy="0"/>
-          <a:chOff x="0" y="0"/>
-          <a:chExt cx="0" cy="0"/>
-        </a:xfrm>
-      </p:grpSpPr>
-      <p:pic>
-        <p:nvPicPr>
-          <p:cNvPr id="5" name="Picture 4">
-            <a:extLst>
-              <a:ext uri="{FF2B5EF4-FFF2-40B4-BE49-F238E27FC236}">
-                <a16:creationId xmlns:a16="http://schemas.microsoft.com/office/drawing/2014/main" id="{34186BFD-4D32-6F06-6690-29A945916E9F}"/>
-              </a:ext>
-            </a:extLst>
-          </p:cNvPr>
-          <p:cNvPicPr>
-            <a:picLocks noChangeAspect="1"/>
-          </p:cNvPicPr>
-          <p:nvPr/>
-        </p:nvPicPr>
-        <p:blipFill>
-          <a:blip r:embed="rId2"/>
-          <a:stretch>
-            <a:fillRect/>
-          </a:stretch>
-        </p:blipFill>
-        <p:spPr>
-          <a:xfrm>
-            <a:off x="1355725" y="700902"/>
-            <a:ext cx="9480550" cy="5456196"/>
-          </a:xfrm>
-          <a:prstGeom prst="rect">
-            <a:avLst/>
-          </a:prstGeom>
-        </p:spPr>
-      </p:pic>
-    </p:spTree>
-    <p:extLst>
-      <p:ext uri="{BB962C8B-B14F-4D97-AF65-F5344CB8AC3E}">
-        <p14:creationId xmlns:p14="http://schemas.microsoft.com/office/powerpoint/2010/main" val="1264065741"/>
-      </p:ext>
-    </p:extLst>
-  </p:cSld>
-  <p:clrMapOvr>
-    <a:masterClrMapping/>
-  </p:clrMapOvr>
-</p:sld>
-</file>
-
-<file path=ppt/slides/slide4.xml><?xml version="1.0" encoding="utf-8"?>
-<p:sld xmlns:a="http://schemas.openxmlformats.org/drawingml/2006/main" xmlns:r="http://schemas.openxmlformats.org/officeDocument/2006/relationships" xmlns:p="http://schemas.openxmlformats.org/presentationml/2006/main">
-  <p:cSld>
-    <p:spTree>
-      <p:nvGrpSpPr>
-        <p:cNvPr id="1" name=""/>
-        <p:cNvGrpSpPr/>
-        <p:nvPr/>
-      </p:nvGrpSpPr>
-      <p:grpSpPr>
-        <a:xfrm>
-          <a:off x="0" y="0"/>
-          <a:ext cx="0" cy="0"/>
-          <a:chOff x="0" y="0"/>
-          <a:chExt cx="0" cy="0"/>
-        </a:xfrm>
-      </p:grpSpPr>
-      <p:pic>
-        <p:nvPicPr>
-          <p:cNvPr id="3" name="Picture 2">
-            <a:extLst>
-              <a:ext uri="{FF2B5EF4-FFF2-40B4-BE49-F238E27FC236}">
-                <a16:creationId xmlns:a16="http://schemas.microsoft.com/office/drawing/2014/main" id="{A0E52E99-419F-5F59-B3FB-9FE958F8A333}"/>
-              </a:ext>
-            </a:extLst>
-          </p:cNvPr>
-          <p:cNvPicPr>
-            <a:picLocks noChangeAspect="1"/>
-          </p:cNvPicPr>
-          <p:nvPr/>
-        </p:nvPicPr>
-        <p:blipFill>
-          <a:blip r:embed="rId2"/>
-          <a:stretch>
-            <a:fillRect/>
-          </a:stretch>
-        </p:blipFill>
-        <p:spPr>
-          <a:xfrm>
-            <a:off x="1619250" y="831017"/>
-            <a:ext cx="8953500" cy="5195966"/>
-          </a:xfrm>
-          <a:prstGeom prst="rect">
-            <a:avLst/>
-          </a:prstGeom>
-        </p:spPr>
-      </p:pic>
-    </p:spTree>
-    <p:extLst>
-      <p:ext uri="{BB962C8B-B14F-4D97-AF65-F5344CB8AC3E}">
-        <p14:creationId xmlns:p14="http://schemas.microsoft.com/office/powerpoint/2010/main" val="3103841934"/>
       </p:ext>
     </p:extLst>
   </p:cSld>

</xml_diff>

<commit_message>
Week 10 Slide Updates
</commit_message>
<xml_diff>
--- a/Weekly Reports/slides/4-abigail-duran.pptx
+++ b/Weekly Reports/slides/4-abigail-duran.pptx
@@ -4,10 +4,13 @@
   <p:sldMasterIdLst>
     <p:sldMasterId id="2147483648" r:id="rId1"/>
   </p:sldMasterIdLst>
+  <p:notesMasterIdLst>
+    <p:notesMasterId r:id="rId5"/>
+  </p:notesMasterIdLst>
   <p:sldIdLst>
     <p:sldId id="257" r:id="rId2"/>
-    <p:sldId id="259" r:id="rId3"/>
-    <p:sldId id="258" r:id="rId4"/>
+    <p:sldId id="258" r:id="rId3"/>
+    <p:sldId id="259" r:id="rId4"/>
   </p:sldIdLst>
   <p:sldSz cx="12192000" cy="6858000"/>
   <p:notesSz cx="6858000" cy="9144000"/>
@@ -114,6 +117,439 @@
 </p:presentation>
 </file>
 
+<file path=ppt/notesMasters/notesMaster1.xml><?xml version="1.0" encoding="utf-8"?>
+<p:notesMaster xmlns:a="http://schemas.openxmlformats.org/drawingml/2006/main" xmlns:r="http://schemas.openxmlformats.org/officeDocument/2006/relationships" xmlns:p="http://schemas.openxmlformats.org/presentationml/2006/main">
+  <p:cSld>
+    <p:bg>
+      <p:bgRef idx="1001">
+        <a:schemeClr val="bg1"/>
+      </p:bgRef>
+    </p:bg>
+    <p:spTree>
+      <p:nvGrpSpPr>
+        <p:cNvPr id="1" name=""/>
+        <p:cNvGrpSpPr/>
+        <p:nvPr/>
+      </p:nvGrpSpPr>
+      <p:grpSpPr>
+        <a:xfrm>
+          <a:off x="0" y="0"/>
+          <a:ext cx="0" cy="0"/>
+          <a:chOff x="0" y="0"/>
+          <a:chExt cx="0" cy="0"/>
+        </a:xfrm>
+      </p:grpSpPr>
+      <p:sp>
+        <p:nvSpPr>
+          <p:cNvPr id="2" name="Header Placeholder 1"/>
+          <p:cNvSpPr>
+            <a:spLocks noGrp="1"/>
+          </p:cNvSpPr>
+          <p:nvPr>
+            <p:ph type="hdr" sz="quarter"/>
+          </p:nvPr>
+        </p:nvSpPr>
+        <p:spPr>
+          <a:xfrm>
+            <a:off x="0" y="0"/>
+            <a:ext cx="2971800" cy="458788"/>
+          </a:xfrm>
+          <a:prstGeom prst="rect">
+            <a:avLst/>
+          </a:prstGeom>
+        </p:spPr>
+        <p:txBody>
+          <a:bodyPr vert="horz" lIns="91440" tIns="45720" rIns="91440" bIns="45720" rtlCol="0"/>
+          <a:lstStyle>
+            <a:lvl1pPr algn="l">
+              <a:defRPr sz="1200"/>
+            </a:lvl1pPr>
+          </a:lstStyle>
+          <a:p>
+            <a:endParaRPr lang="en-US"/>
+          </a:p>
+        </p:txBody>
+      </p:sp>
+      <p:sp>
+        <p:nvSpPr>
+          <p:cNvPr id="3" name="Date Placeholder 2"/>
+          <p:cNvSpPr>
+            <a:spLocks noGrp="1"/>
+          </p:cNvSpPr>
+          <p:nvPr>
+            <p:ph type="dt" idx="1"/>
+          </p:nvPr>
+        </p:nvSpPr>
+        <p:spPr>
+          <a:xfrm>
+            <a:off x="3884613" y="0"/>
+            <a:ext cx="2971800" cy="458788"/>
+          </a:xfrm>
+          <a:prstGeom prst="rect">
+            <a:avLst/>
+          </a:prstGeom>
+        </p:spPr>
+        <p:txBody>
+          <a:bodyPr vert="horz" lIns="91440" tIns="45720" rIns="91440" bIns="45720" rtlCol="0"/>
+          <a:lstStyle>
+            <a:lvl1pPr algn="r">
+              <a:defRPr sz="1200"/>
+            </a:lvl1pPr>
+          </a:lstStyle>
+          <a:p>
+            <a:fld id="{E2E46CE4-1CF6-BD4C-943E-A9146691DC73}" type="datetimeFigureOut">
+              <a:rPr lang="en-US" smtClean="0"/>
+              <a:t>10/27/26</a:t>
+            </a:fld>
+            <a:endParaRPr lang="en-US"/>
+          </a:p>
+        </p:txBody>
+      </p:sp>
+      <p:sp>
+        <p:nvSpPr>
+          <p:cNvPr id="4" name="Slide Image Placeholder 3"/>
+          <p:cNvSpPr>
+            <a:spLocks noGrp="1" noRot="1" noChangeAspect="1"/>
+          </p:cNvSpPr>
+          <p:nvPr>
+            <p:ph type="sldImg" idx="2"/>
+          </p:nvPr>
+        </p:nvSpPr>
+        <p:spPr>
+          <a:xfrm>
+            <a:off x="685800" y="1143000"/>
+            <a:ext cx="5486400" cy="3086100"/>
+          </a:xfrm>
+          <a:prstGeom prst="rect">
+            <a:avLst/>
+          </a:prstGeom>
+          <a:noFill/>
+          <a:ln w="12700">
+            <a:solidFill>
+              <a:prstClr val="black"/>
+            </a:solidFill>
+          </a:ln>
+        </p:spPr>
+        <p:txBody>
+          <a:bodyPr vert="horz" lIns="91440" tIns="45720" rIns="91440" bIns="45720" rtlCol="0" anchor="ctr"/>
+          <a:lstStyle/>
+          <a:p>
+            <a:endParaRPr lang="en-US"/>
+          </a:p>
+        </p:txBody>
+      </p:sp>
+      <p:sp>
+        <p:nvSpPr>
+          <p:cNvPr id="5" name="Notes Placeholder 4"/>
+          <p:cNvSpPr>
+            <a:spLocks noGrp="1"/>
+          </p:cNvSpPr>
+          <p:nvPr>
+            <p:ph type="body" sz="quarter" idx="3"/>
+          </p:nvPr>
+        </p:nvSpPr>
+        <p:spPr>
+          <a:xfrm>
+            <a:off x="685800" y="4400550"/>
+            <a:ext cx="5486400" cy="3600450"/>
+          </a:xfrm>
+          <a:prstGeom prst="rect">
+            <a:avLst/>
+          </a:prstGeom>
+        </p:spPr>
+        <p:txBody>
+          <a:bodyPr vert="horz" lIns="91440" tIns="45720" rIns="91440" bIns="45720" rtlCol="0"/>
+          <a:lstStyle/>
+          <a:p>
+            <a:pPr lvl="0"/>
+            <a:r>
+              <a:rPr lang="en-US"/>
+              <a:t>Click to edit Master text styles</a:t>
+            </a:r>
+          </a:p>
+          <a:p>
+            <a:pPr lvl="1"/>
+            <a:r>
+              <a:rPr lang="en-US"/>
+              <a:t>Second level</a:t>
+            </a:r>
+          </a:p>
+          <a:p>
+            <a:pPr lvl="2"/>
+            <a:r>
+              <a:rPr lang="en-US"/>
+              <a:t>Third level</a:t>
+            </a:r>
+          </a:p>
+          <a:p>
+            <a:pPr lvl="3"/>
+            <a:r>
+              <a:rPr lang="en-US"/>
+              <a:t>Fourth level</a:t>
+            </a:r>
+          </a:p>
+          <a:p>
+            <a:pPr lvl="4"/>
+            <a:r>
+              <a:rPr lang="en-US"/>
+              <a:t>Fifth level</a:t>
+            </a:r>
+          </a:p>
+        </p:txBody>
+      </p:sp>
+      <p:sp>
+        <p:nvSpPr>
+          <p:cNvPr id="6" name="Footer Placeholder 5"/>
+          <p:cNvSpPr>
+            <a:spLocks noGrp="1"/>
+          </p:cNvSpPr>
+          <p:nvPr>
+            <p:ph type="ftr" sz="quarter" idx="4"/>
+          </p:nvPr>
+        </p:nvSpPr>
+        <p:spPr>
+          <a:xfrm>
+            <a:off x="0" y="8685213"/>
+            <a:ext cx="2971800" cy="458787"/>
+          </a:xfrm>
+          <a:prstGeom prst="rect">
+            <a:avLst/>
+          </a:prstGeom>
+        </p:spPr>
+        <p:txBody>
+          <a:bodyPr vert="horz" lIns="91440" tIns="45720" rIns="91440" bIns="45720" rtlCol="0" anchor="b"/>
+          <a:lstStyle>
+            <a:lvl1pPr algn="l">
+              <a:defRPr sz="1200"/>
+            </a:lvl1pPr>
+          </a:lstStyle>
+          <a:p>
+            <a:endParaRPr lang="en-US"/>
+          </a:p>
+        </p:txBody>
+      </p:sp>
+      <p:sp>
+        <p:nvSpPr>
+          <p:cNvPr id="7" name="Slide Number Placeholder 6"/>
+          <p:cNvSpPr>
+            <a:spLocks noGrp="1"/>
+          </p:cNvSpPr>
+          <p:nvPr>
+            <p:ph type="sldNum" sz="quarter" idx="5"/>
+          </p:nvPr>
+        </p:nvSpPr>
+        <p:spPr>
+          <a:xfrm>
+            <a:off x="3884613" y="8685213"/>
+            <a:ext cx="2971800" cy="458787"/>
+          </a:xfrm>
+          <a:prstGeom prst="rect">
+            <a:avLst/>
+          </a:prstGeom>
+        </p:spPr>
+        <p:txBody>
+          <a:bodyPr vert="horz" lIns="91440" tIns="45720" rIns="91440" bIns="45720" rtlCol="0" anchor="b"/>
+          <a:lstStyle>
+            <a:lvl1pPr algn="r">
+              <a:defRPr sz="1200"/>
+            </a:lvl1pPr>
+          </a:lstStyle>
+          <a:p>
+            <a:fld id="{14DD562A-EC08-1F4C-B151-E0A2BED27C4D}" type="slidenum">
+              <a:rPr lang="en-US" smtClean="0"/>
+              <a:t>‹#›</a:t>
+            </a:fld>
+            <a:endParaRPr lang="en-US"/>
+          </a:p>
+        </p:txBody>
+      </p:sp>
+    </p:spTree>
+    <p:extLst>
+      <p:ext uri="{BB962C8B-B14F-4D97-AF65-F5344CB8AC3E}">
+        <p14:creationId xmlns:p14="http://schemas.microsoft.com/office/powerpoint/2010/main" val="3978098103"/>
+      </p:ext>
+    </p:extLst>
+  </p:cSld>
+  <p:clrMap bg1="lt1" tx1="dk1" bg2="lt2" tx2="dk2" accent1="accent1" accent2="accent2" accent3="accent3" accent4="accent4" accent5="accent5" accent6="accent6" hlink="hlink" folHlink="folHlink"/>
+  <p:notesStyle>
+    <a:lvl1pPr marL="0" algn="l" defTabSz="914400" rtl="0" eaLnBrk="1" latinLnBrk="0" hangingPunct="1">
+      <a:defRPr sz="1200" kern="1200">
+        <a:solidFill>
+          <a:schemeClr val="tx1"/>
+        </a:solidFill>
+        <a:latin typeface="+mn-lt"/>
+        <a:ea typeface="+mn-ea"/>
+        <a:cs typeface="+mn-cs"/>
+      </a:defRPr>
+    </a:lvl1pPr>
+    <a:lvl2pPr marL="457200" algn="l" defTabSz="914400" rtl="0" eaLnBrk="1" latinLnBrk="0" hangingPunct="1">
+      <a:defRPr sz="1200" kern="1200">
+        <a:solidFill>
+          <a:schemeClr val="tx1"/>
+        </a:solidFill>
+        <a:latin typeface="+mn-lt"/>
+        <a:ea typeface="+mn-ea"/>
+        <a:cs typeface="+mn-cs"/>
+      </a:defRPr>
+    </a:lvl2pPr>
+    <a:lvl3pPr marL="914400" algn="l" defTabSz="914400" rtl="0" eaLnBrk="1" latinLnBrk="0" hangingPunct="1">
+      <a:defRPr sz="1200" kern="1200">
+        <a:solidFill>
+          <a:schemeClr val="tx1"/>
+        </a:solidFill>
+        <a:latin typeface="+mn-lt"/>
+        <a:ea typeface="+mn-ea"/>
+        <a:cs typeface="+mn-cs"/>
+      </a:defRPr>
+    </a:lvl3pPr>
+    <a:lvl4pPr marL="1371600" algn="l" defTabSz="914400" rtl="0" eaLnBrk="1" latinLnBrk="0" hangingPunct="1">
+      <a:defRPr sz="1200" kern="1200">
+        <a:solidFill>
+          <a:schemeClr val="tx1"/>
+        </a:solidFill>
+        <a:latin typeface="+mn-lt"/>
+        <a:ea typeface="+mn-ea"/>
+        <a:cs typeface="+mn-cs"/>
+      </a:defRPr>
+    </a:lvl4pPr>
+    <a:lvl5pPr marL="1828800" algn="l" defTabSz="914400" rtl="0" eaLnBrk="1" latinLnBrk="0" hangingPunct="1">
+      <a:defRPr sz="1200" kern="1200">
+        <a:solidFill>
+          <a:schemeClr val="tx1"/>
+        </a:solidFill>
+        <a:latin typeface="+mn-lt"/>
+        <a:ea typeface="+mn-ea"/>
+        <a:cs typeface="+mn-cs"/>
+      </a:defRPr>
+    </a:lvl5pPr>
+    <a:lvl6pPr marL="2286000" algn="l" defTabSz="914400" rtl="0" eaLnBrk="1" latinLnBrk="0" hangingPunct="1">
+      <a:defRPr sz="1200" kern="1200">
+        <a:solidFill>
+          <a:schemeClr val="tx1"/>
+        </a:solidFill>
+        <a:latin typeface="+mn-lt"/>
+        <a:ea typeface="+mn-ea"/>
+        <a:cs typeface="+mn-cs"/>
+      </a:defRPr>
+    </a:lvl6pPr>
+    <a:lvl7pPr marL="2743200" algn="l" defTabSz="914400" rtl="0" eaLnBrk="1" latinLnBrk="0" hangingPunct="1">
+      <a:defRPr sz="1200" kern="1200">
+        <a:solidFill>
+          <a:schemeClr val="tx1"/>
+        </a:solidFill>
+        <a:latin typeface="+mn-lt"/>
+        <a:ea typeface="+mn-ea"/>
+        <a:cs typeface="+mn-cs"/>
+      </a:defRPr>
+    </a:lvl7pPr>
+    <a:lvl8pPr marL="3200400" algn="l" defTabSz="914400" rtl="0" eaLnBrk="1" latinLnBrk="0" hangingPunct="1">
+      <a:defRPr sz="1200" kern="1200">
+        <a:solidFill>
+          <a:schemeClr val="tx1"/>
+        </a:solidFill>
+        <a:latin typeface="+mn-lt"/>
+        <a:ea typeface="+mn-ea"/>
+        <a:cs typeface="+mn-cs"/>
+      </a:defRPr>
+    </a:lvl8pPr>
+    <a:lvl9pPr marL="3657600" algn="l" defTabSz="914400" rtl="0" eaLnBrk="1" latinLnBrk="0" hangingPunct="1">
+      <a:defRPr sz="1200" kern="1200">
+        <a:solidFill>
+          <a:schemeClr val="tx1"/>
+        </a:solidFill>
+        <a:latin typeface="+mn-lt"/>
+        <a:ea typeface="+mn-ea"/>
+        <a:cs typeface="+mn-cs"/>
+      </a:defRPr>
+    </a:lvl9pPr>
+  </p:notesStyle>
+</p:notesMaster>
+</file>
+
+<file path=ppt/notesSlides/notesSlide1.xml><?xml version="1.0" encoding="utf-8"?>
+<p:notes xmlns:a="http://schemas.openxmlformats.org/drawingml/2006/main" xmlns:r="http://schemas.openxmlformats.org/officeDocument/2006/relationships" xmlns:p="http://schemas.openxmlformats.org/presentationml/2006/main">
+  <p:cSld>
+    <p:spTree>
+      <p:nvGrpSpPr>
+        <p:cNvPr id="1" name=""/>
+        <p:cNvGrpSpPr/>
+        <p:nvPr/>
+      </p:nvGrpSpPr>
+      <p:grpSpPr>
+        <a:xfrm>
+          <a:off x="0" y="0"/>
+          <a:ext cx="0" cy="0"/>
+          <a:chOff x="0" y="0"/>
+          <a:chExt cx="0" cy="0"/>
+        </a:xfrm>
+      </p:grpSpPr>
+      <p:sp>
+        <p:nvSpPr>
+          <p:cNvPr id="2" name="Slide Image Placeholder 1"/>
+          <p:cNvSpPr>
+            <a:spLocks noGrp="1" noRot="1" noChangeAspect="1"/>
+          </p:cNvSpPr>
+          <p:nvPr>
+            <p:ph type="sldImg"/>
+          </p:nvPr>
+        </p:nvSpPr>
+        <p:spPr/>
+      </p:sp>
+      <p:sp>
+        <p:nvSpPr>
+          <p:cNvPr id="3" name="Notes Placeholder 2"/>
+          <p:cNvSpPr>
+            <a:spLocks noGrp="1"/>
+          </p:cNvSpPr>
+          <p:nvPr>
+            <p:ph type="body" idx="1"/>
+          </p:nvPr>
+        </p:nvSpPr>
+        <p:spPr/>
+        <p:txBody>
+          <a:bodyPr/>
+          <a:lstStyle/>
+          <a:p>
+            <a:endParaRPr lang="en-US" dirty="0"/>
+          </a:p>
+        </p:txBody>
+      </p:sp>
+      <p:sp>
+        <p:nvSpPr>
+          <p:cNvPr id="4" name="Slide Number Placeholder 3"/>
+          <p:cNvSpPr>
+            <a:spLocks noGrp="1"/>
+          </p:cNvSpPr>
+          <p:nvPr>
+            <p:ph type="sldNum" sz="quarter" idx="5"/>
+          </p:nvPr>
+        </p:nvSpPr>
+        <p:spPr/>
+        <p:txBody>
+          <a:bodyPr/>
+          <a:lstStyle/>
+          <a:p>
+            <a:fld id="{14DD562A-EC08-1F4C-B151-E0A2BED27C4D}" type="slidenum">
+              <a:rPr lang="en-US" smtClean="0"/>
+              <a:t>2</a:t>
+            </a:fld>
+            <a:endParaRPr lang="en-US"/>
+          </a:p>
+        </p:txBody>
+      </p:sp>
+    </p:spTree>
+    <p:extLst>
+      <p:ext uri="{BB962C8B-B14F-4D97-AF65-F5344CB8AC3E}">
+        <p14:creationId xmlns:p14="http://schemas.microsoft.com/office/powerpoint/2010/main" val="3873717555"/>
+      </p:ext>
+    </p:extLst>
+  </p:cSld>
+  <p:clrMapOvr>
+    <a:masterClrMapping/>
+  </p:clrMapOvr>
+</p:notes>
+</file>
+
 <file path=ppt/slideLayouts/slideLayout1.xml><?xml version="1.0" encoding="utf-8"?>
 <p:sldLayout xmlns:a="http://schemas.openxmlformats.org/drawingml/2006/main" xmlns:r="http://schemas.openxmlformats.org/officeDocument/2006/relationships" xmlns:p="http://schemas.openxmlformats.org/presentationml/2006/main" type="title" preserve="1">
   <p:cSld name="Title Slide">
@@ -261,7 +697,7 @@
           <a:p>
             <a:fld id="{752E6B35-DAD5-CF47-9E65-9CA12B499D8C}" type="datetimeFigureOut">
               <a:rPr lang="en-US" smtClean="0"/>
-              <a:t>10/19/26</a:t>
+              <a:t>10/27/26</a:t>
             </a:fld>
             <a:endParaRPr lang="en-US"/>
           </a:p>
@@ -459,7 +895,7 @@
           <a:p>
             <a:fld id="{752E6B35-DAD5-CF47-9E65-9CA12B499D8C}" type="datetimeFigureOut">
               <a:rPr lang="en-US" smtClean="0"/>
-              <a:t>10/19/26</a:t>
+              <a:t>10/27/26</a:t>
             </a:fld>
             <a:endParaRPr lang="en-US"/>
           </a:p>
@@ -667,7 +1103,7 @@
           <a:p>
             <a:fld id="{752E6B35-DAD5-CF47-9E65-9CA12B499D8C}" type="datetimeFigureOut">
               <a:rPr lang="en-US" smtClean="0"/>
-              <a:t>10/19/26</a:t>
+              <a:t>10/27/26</a:t>
             </a:fld>
             <a:endParaRPr lang="en-US"/>
           </a:p>
@@ -865,7 +1301,7 @@
           <a:p>
             <a:fld id="{752E6B35-DAD5-CF47-9E65-9CA12B499D8C}" type="datetimeFigureOut">
               <a:rPr lang="en-US" smtClean="0"/>
-              <a:t>10/19/26</a:t>
+              <a:t>10/27/26</a:t>
             </a:fld>
             <a:endParaRPr lang="en-US"/>
           </a:p>
@@ -1140,7 +1576,7 @@
           <a:p>
             <a:fld id="{752E6B35-DAD5-CF47-9E65-9CA12B499D8C}" type="datetimeFigureOut">
               <a:rPr lang="en-US" smtClean="0"/>
-              <a:t>10/19/26</a:t>
+              <a:t>10/27/26</a:t>
             </a:fld>
             <a:endParaRPr lang="en-US"/>
           </a:p>
@@ -1405,7 +1841,7 @@
           <a:p>
             <a:fld id="{752E6B35-DAD5-CF47-9E65-9CA12B499D8C}" type="datetimeFigureOut">
               <a:rPr lang="en-US" smtClean="0"/>
-              <a:t>10/19/26</a:t>
+              <a:t>10/27/26</a:t>
             </a:fld>
             <a:endParaRPr lang="en-US"/>
           </a:p>
@@ -1817,7 +2253,7 @@
           <a:p>
             <a:fld id="{752E6B35-DAD5-CF47-9E65-9CA12B499D8C}" type="datetimeFigureOut">
               <a:rPr lang="en-US" smtClean="0"/>
-              <a:t>10/19/26</a:t>
+              <a:t>10/27/26</a:t>
             </a:fld>
             <a:endParaRPr lang="en-US"/>
           </a:p>
@@ -1958,7 +2394,7 @@
           <a:p>
             <a:fld id="{752E6B35-DAD5-CF47-9E65-9CA12B499D8C}" type="datetimeFigureOut">
               <a:rPr lang="en-US" smtClean="0"/>
-              <a:t>10/19/26</a:t>
+              <a:t>10/27/26</a:t>
             </a:fld>
             <a:endParaRPr lang="en-US"/>
           </a:p>
@@ -2071,7 +2507,7 @@
           <a:p>
             <a:fld id="{752E6B35-DAD5-CF47-9E65-9CA12B499D8C}" type="datetimeFigureOut">
               <a:rPr lang="en-US" smtClean="0"/>
-              <a:t>10/19/26</a:t>
+              <a:t>10/27/26</a:t>
             </a:fld>
             <a:endParaRPr lang="en-US"/>
           </a:p>
@@ -2382,7 +2818,7 @@
           <a:p>
             <a:fld id="{752E6B35-DAD5-CF47-9E65-9CA12B499D8C}" type="datetimeFigureOut">
               <a:rPr lang="en-US" smtClean="0"/>
-              <a:t>10/19/26</a:t>
+              <a:t>10/27/26</a:t>
             </a:fld>
             <a:endParaRPr lang="en-US"/>
           </a:p>
@@ -2670,7 +3106,7 @@
           <a:p>
             <a:fld id="{752E6B35-DAD5-CF47-9E65-9CA12B499D8C}" type="datetimeFigureOut">
               <a:rPr lang="en-US" smtClean="0"/>
-              <a:t>10/19/26</a:t>
+              <a:t>10/27/26</a:t>
             </a:fld>
             <a:endParaRPr lang="en-US"/>
           </a:p>
@@ -2911,7 +3347,7 @@
           <a:p>
             <a:fld id="{752E6B35-DAD5-CF47-9E65-9CA12B499D8C}" type="datetimeFigureOut">
               <a:rPr lang="en-US" smtClean="0"/>
-              <a:t>10/19/26</a:t>
+              <a:t>10/27/26</a:t>
             </a:fld>
             <a:endParaRPr lang="en-US"/>
           </a:p>
@@ -3379,7 +3815,7 @@
         </p:spPr>
         <p:txBody>
           <a:bodyPr>
-            <a:normAutofit fontScale="77500" lnSpcReduction="20000"/>
+            <a:normAutofit fontScale="92500" lnSpcReduction="10000"/>
           </a:bodyPr>
           <a:lstStyle/>
           <a:p>
@@ -3393,7 +3829,7 @@
             <a:pPr lvl="1"/>
             <a:r>
               <a:rPr lang="en-US" dirty="0"/>
-              <a:t>Prepare the PCB design files with all currently selected components and required connections.</a:t>
+              <a:t>Complete final design of the PCB</a:t>
             </a:r>
           </a:p>
           <a:p>
@@ -3421,21 +3857,14 @@
             <a:pPr lvl="1"/>
             <a:r>
               <a:rPr lang="en-US" dirty="0"/>
-              <a:t>Created an organized component checklist/spreadsheet for the PCB design. </a:t>
+              <a:t>Added the required new components</a:t>
             </a:r>
           </a:p>
           <a:p>
             <a:pPr lvl="1"/>
             <a:r>
               <a:rPr lang="en-US" dirty="0"/>
-              <a:t>Reviewed the CM5 IO Board components and connections to determine which features should be kept, removed, or modified.</a:t>
-            </a:r>
-          </a:p>
-          <a:p>
-            <a:pPr lvl="1"/>
-            <a:r>
-              <a:rPr lang="en-US" dirty="0"/>
-              <a:t>Added IMU and LCD connectors on the board.</a:t>
+              <a:t>Began tracing the connections on the board</a:t>
             </a:r>
           </a:p>
           <a:p>
@@ -3452,14 +3881,14 @@
             <a:pPr lvl="1"/>
             <a:r>
               <a:rPr lang="en-US" dirty="0"/>
-              <a:t>Continue developing the PCB design and component placement.</a:t>
+              <a:t>Generate all required files for manufacturing.</a:t>
             </a:r>
           </a:p>
           <a:p>
             <a:pPr lvl="1"/>
             <a:r>
               <a:rPr lang="en-US" dirty="0"/>
-              <a:t>Work toward finalizing the PCB design for manufacturing.</a:t>
+              <a:t>Place the PCB order.</a:t>
             </a:r>
             <a:endParaRPr dirty="0"/>
           </a:p>
@@ -3496,66 +3925,6 @@
 </file>
 
 <file path=ppt/slides/slide2.xml><?xml version="1.0" encoding="utf-8"?>
-<p:sld xmlns:a="http://schemas.openxmlformats.org/drawingml/2006/main" xmlns:r="http://schemas.openxmlformats.org/officeDocument/2006/relationships" xmlns:p="http://schemas.openxmlformats.org/presentationml/2006/main">
-  <p:cSld>
-    <p:spTree>
-      <p:nvGrpSpPr>
-        <p:cNvPr id="1" name=""/>
-        <p:cNvGrpSpPr/>
-        <p:nvPr/>
-      </p:nvGrpSpPr>
-      <p:grpSpPr>
-        <a:xfrm>
-          <a:off x="0" y="0"/>
-          <a:ext cx="0" cy="0"/>
-          <a:chOff x="0" y="0"/>
-          <a:chExt cx="0" cy="0"/>
-        </a:xfrm>
-      </p:grpSpPr>
-      <p:pic>
-        <p:nvPicPr>
-          <p:cNvPr id="3" name="Picture 2">
-            <a:extLst>
-              <a:ext uri="{FF2B5EF4-FFF2-40B4-BE49-F238E27FC236}">
-                <a16:creationId xmlns:a16="http://schemas.microsoft.com/office/drawing/2014/main" id="{B71870F1-2187-FBD8-D06D-8778AEBE17D5}"/>
-              </a:ext>
-            </a:extLst>
-          </p:cNvPr>
-          <p:cNvPicPr>
-            <a:picLocks noChangeAspect="1"/>
-          </p:cNvPicPr>
-          <p:nvPr/>
-        </p:nvPicPr>
-        <p:blipFill>
-          <a:blip r:embed="rId2"/>
-          <a:stretch>
-            <a:fillRect/>
-          </a:stretch>
-        </p:blipFill>
-        <p:spPr>
-          <a:xfrm>
-            <a:off x="1342371" y="1531408"/>
-            <a:ext cx="9507257" cy="3795183"/>
-          </a:xfrm>
-          <a:prstGeom prst="rect">
-            <a:avLst/>
-          </a:prstGeom>
-        </p:spPr>
-      </p:pic>
-    </p:spTree>
-    <p:extLst>
-      <p:ext uri="{BB962C8B-B14F-4D97-AF65-F5344CB8AC3E}">
-        <p14:creationId xmlns:p14="http://schemas.microsoft.com/office/powerpoint/2010/main" val="1097263825"/>
-      </p:ext>
-    </p:extLst>
-  </p:cSld>
-  <p:clrMapOvr>
-    <a:masterClrMapping/>
-  </p:clrMapOvr>
-</p:sld>
-</file>
-
-<file path=ppt/slides/slide3.xml><?xml version="1.0" encoding="utf-8"?>
 <p:sld xmlns:a="http://schemas.openxmlformats.org/drawingml/2006/main" xmlns:r="http://schemas.openxmlformats.org/officeDocument/2006/relationships" xmlns:p="http://schemas.openxmlformats.org/presentationml/2006/main">
   <p:cSld>
     <p:bg>
@@ -3750,7 +4119,7 @@
           <p:nvPr/>
         </p:nvPicPr>
         <p:blipFill>
-          <a:blip r:embed="rId2"/>
+          <a:blip r:embed="rId3"/>
           <a:stretch>
             <a:fillRect/>
           </a:stretch>
@@ -3765,10 +4134,140 @@
           </a:prstGeom>
         </p:spPr>
       </p:pic>
+      <p:sp>
+        <p:nvSpPr>
+          <p:cNvPr id="2" name="TextBox 1">
+            <a:extLst>
+              <a:ext uri="{FF2B5EF4-FFF2-40B4-BE49-F238E27FC236}">
+                <a16:creationId xmlns:a16="http://schemas.microsoft.com/office/drawing/2014/main" id="{6350B74D-6365-F884-1022-AF319FB7D4EF}"/>
+              </a:ext>
+            </a:extLst>
+          </p:cNvPr>
+          <p:cNvSpPr txBox="1"/>
+          <p:nvPr/>
+        </p:nvSpPr>
+        <p:spPr>
+          <a:xfrm>
+            <a:off x="1326797" y="6410366"/>
+            <a:ext cx="1589859" cy="369332"/>
+          </a:xfrm>
+          <a:prstGeom prst="rect">
+            <a:avLst/>
+          </a:prstGeom>
+          <a:noFill/>
+        </p:spPr>
+        <p:txBody>
+          <a:bodyPr wrap="none" rtlCol="0">
+            <a:spAutoFit/>
+          </a:bodyPr>
+          <a:lstStyle/>
+          <a:p>
+            <a:r>
+              <a:rPr lang="en-US" dirty="0"/>
+              <a:t>6.2 in by 3.5 in</a:t>
+            </a:r>
+          </a:p>
+        </p:txBody>
+      </p:sp>
     </p:spTree>
     <p:extLst>
       <p:ext uri="{BB962C8B-B14F-4D97-AF65-F5344CB8AC3E}">
         <p14:creationId xmlns:p14="http://schemas.microsoft.com/office/powerpoint/2010/main" val="440385375"/>
+      </p:ext>
+    </p:extLst>
+  </p:cSld>
+  <p:clrMapOvr>
+    <a:masterClrMapping/>
+  </p:clrMapOvr>
+</p:sld>
+</file>
+
+<file path=ppt/slides/slide3.xml><?xml version="1.0" encoding="utf-8"?>
+<p:sld xmlns:a="http://schemas.openxmlformats.org/drawingml/2006/main" xmlns:r="http://schemas.openxmlformats.org/officeDocument/2006/relationships" xmlns:p="http://schemas.openxmlformats.org/presentationml/2006/main">
+  <p:cSld>
+    <p:spTree>
+      <p:nvGrpSpPr>
+        <p:cNvPr id="1" name=""/>
+        <p:cNvGrpSpPr/>
+        <p:nvPr/>
+      </p:nvGrpSpPr>
+      <p:grpSpPr>
+        <a:xfrm>
+          <a:off x="0" y="0"/>
+          <a:ext cx="0" cy="0"/>
+          <a:chOff x="0" y="0"/>
+          <a:chExt cx="0" cy="0"/>
+        </a:xfrm>
+      </p:grpSpPr>
+      <p:pic>
+        <p:nvPicPr>
+          <p:cNvPr id="3" name="Picture 2">
+            <a:extLst>
+              <a:ext uri="{FF2B5EF4-FFF2-40B4-BE49-F238E27FC236}">
+                <a16:creationId xmlns:a16="http://schemas.microsoft.com/office/drawing/2014/main" id="{8204D2AF-EE1E-5FD0-C855-52759FF0EA20}"/>
+              </a:ext>
+            </a:extLst>
+          </p:cNvPr>
+          <p:cNvPicPr>
+            <a:picLocks noChangeAspect="1"/>
+          </p:cNvPicPr>
+          <p:nvPr/>
+        </p:nvPicPr>
+        <p:blipFill>
+          <a:blip r:embed="rId2"/>
+          <a:stretch>
+            <a:fillRect/>
+          </a:stretch>
+        </p:blipFill>
+        <p:spPr>
+          <a:xfrm>
+            <a:off x="688040" y="536012"/>
+            <a:ext cx="10815919" cy="5785976"/>
+          </a:xfrm>
+          <a:prstGeom prst="rect">
+            <a:avLst/>
+          </a:prstGeom>
+        </p:spPr>
+      </p:pic>
+      <p:sp>
+        <p:nvSpPr>
+          <p:cNvPr id="5" name="TextBox 4">
+            <a:extLst>
+              <a:ext uri="{FF2B5EF4-FFF2-40B4-BE49-F238E27FC236}">
+                <a16:creationId xmlns:a16="http://schemas.microsoft.com/office/drawing/2014/main" id="{7DFD9DD9-586C-1C00-F0B1-2CEC1B3F432E}"/>
+              </a:ext>
+            </a:extLst>
+          </p:cNvPr>
+          <p:cNvSpPr txBox="1"/>
+          <p:nvPr/>
+        </p:nvSpPr>
+        <p:spPr>
+          <a:xfrm>
+            <a:off x="688040" y="6321988"/>
+            <a:ext cx="1589859" cy="369332"/>
+          </a:xfrm>
+          <a:prstGeom prst="rect">
+            <a:avLst/>
+          </a:prstGeom>
+          <a:noFill/>
+        </p:spPr>
+        <p:txBody>
+          <a:bodyPr wrap="none" rtlCol="0">
+            <a:spAutoFit/>
+          </a:bodyPr>
+          <a:lstStyle/>
+          <a:p>
+            <a:r>
+              <a:rPr lang="en-US" dirty="0"/>
+              <a:t>5.5 in by 2.6 in</a:t>
+            </a:r>
+          </a:p>
+        </p:txBody>
+      </p:sp>
+    </p:spTree>
+    <p:extLst>
+      <p:ext uri="{BB962C8B-B14F-4D97-AF65-F5344CB8AC3E}">
+        <p14:creationId xmlns:p14="http://schemas.microsoft.com/office/powerpoint/2010/main" val="3991605395"/>
       </p:ext>
     </p:extLst>
   </p:cSld>
@@ -4091,4 +4590,319 @@
     </a:ext>
   </a:extLst>
 </a:theme>
+</file>
+
+<file path=ppt/theme/theme2.xml><?xml version="1.0" encoding="utf-8"?>
+<a:theme xmlns:a="http://schemas.openxmlformats.org/drawingml/2006/main" name="Office Theme">
+  <a:themeElements>
+    <a:clrScheme name="Office">
+      <a:dk1>
+        <a:sysClr val="windowText" lastClr="000000"/>
+      </a:dk1>
+      <a:lt1>
+        <a:sysClr val="window" lastClr="FFFFFF"/>
+      </a:lt1>
+      <a:dk2>
+        <a:srgbClr val="0E2841"/>
+      </a:dk2>
+      <a:lt2>
+        <a:srgbClr val="E8E8E8"/>
+      </a:lt2>
+      <a:accent1>
+        <a:srgbClr val="156082"/>
+      </a:accent1>
+      <a:accent2>
+        <a:srgbClr val="E97132"/>
+      </a:accent2>
+      <a:accent3>
+        <a:srgbClr val="196B24"/>
+      </a:accent3>
+      <a:accent4>
+        <a:srgbClr val="0F9ED5"/>
+      </a:accent4>
+      <a:accent5>
+        <a:srgbClr val="A02B93"/>
+      </a:accent5>
+      <a:accent6>
+        <a:srgbClr val="4EA72E"/>
+      </a:accent6>
+      <a:hlink>
+        <a:srgbClr val="467886"/>
+      </a:hlink>
+      <a:folHlink>
+        <a:srgbClr val="96607D"/>
+      </a:folHlink>
+    </a:clrScheme>
+    <a:fontScheme name="Office">
+      <a:majorFont>
+        <a:latin typeface="Aptos Display" panose="02110004020202020204"/>
+        <a:ea typeface=""/>
+        <a:cs typeface=""/>
+        <a:font script="Jpan" typeface="游ゴシック Light"/>
+        <a:font script="Hang" typeface="맑은 고딕"/>
+        <a:font script="Hans" typeface="等线 Light"/>
+        <a:font script="Hant" typeface="新細明體"/>
+        <a:font script="Arab" typeface="Times New Roman"/>
+        <a:font script="Hebr" typeface="Times New Roman"/>
+        <a:font script="Thai" typeface="Angsana New"/>
+        <a:font script="Ethi" typeface="Nyala"/>
+        <a:font script="Beng" typeface="Vrinda"/>
+        <a:font script="Gujr" typeface="Shruti"/>
+        <a:font script="Khmr" typeface="MoolBoran"/>
+        <a:font script="Knda" typeface="Tunga"/>
+        <a:font script="Guru" typeface="Raavi"/>
+        <a:font script="Cans" typeface="Euphemia"/>
+        <a:font script="Cher" typeface="Plantagenet Cherokee"/>
+        <a:font script="Yiii" typeface="Microsoft Yi Baiti"/>
+        <a:font script="Tibt" typeface="Microsoft Himalaya"/>
+        <a:font script="Thaa" typeface="MV Boli"/>
+        <a:font script="Deva" typeface="Mangal"/>
+        <a:font script="Telu" typeface="Gautami"/>
+        <a:font script="Taml" typeface="Latha"/>
+        <a:font script="Syrc" typeface="Estrangelo Edessa"/>
+        <a:font script="Orya" typeface="Kalinga"/>
+        <a:font script="Mlym" typeface="Kartika"/>
+        <a:font script="Laoo" typeface="DokChampa"/>
+        <a:font script="Sinh" typeface="Iskoola Pota"/>
+        <a:font script="Mong" typeface="Mongolian Baiti"/>
+        <a:font script="Viet" typeface="Times New Roman"/>
+        <a:font script="Uigh" typeface="Microsoft Uighur"/>
+        <a:font script="Geor" typeface="Sylfaen"/>
+        <a:font script="Armn" typeface="Arial"/>
+        <a:font script="Bugi" typeface="Leelawadee UI"/>
+        <a:font script="Bopo" typeface="Microsoft JhengHei"/>
+        <a:font script="Java" typeface="Javanese Text"/>
+        <a:font script="Lisu" typeface="Segoe UI"/>
+        <a:font script="Mymr" typeface="Myanmar Text"/>
+        <a:font script="Nkoo" typeface="Ebrima"/>
+        <a:font script="Olck" typeface="Nirmala UI"/>
+        <a:font script="Osma" typeface="Ebrima"/>
+        <a:font script="Phag" typeface="Phagspa"/>
+        <a:font script="Syrn" typeface="Estrangelo Edessa"/>
+        <a:font script="Syrj" typeface="Estrangelo Edessa"/>
+        <a:font script="Syre" typeface="Estrangelo Edessa"/>
+        <a:font script="Sora" typeface="Nirmala UI"/>
+        <a:font script="Tale" typeface="Microsoft Tai Le"/>
+        <a:font script="Talu" typeface="Microsoft New Tai Lue"/>
+        <a:font script="Tfng" typeface="Ebrima"/>
+      </a:majorFont>
+      <a:minorFont>
+        <a:latin typeface="Aptos" panose="02110004020202020204"/>
+        <a:ea typeface=""/>
+        <a:cs typeface=""/>
+        <a:font script="Jpan" typeface="游ゴシック"/>
+        <a:font script="Hang" typeface="맑은 고딕"/>
+        <a:font script="Hans" typeface="等线"/>
+        <a:font script="Hant" typeface="新細明體"/>
+        <a:font script="Arab" typeface="Arial"/>
+        <a:font script="Hebr" typeface="Arial"/>
+        <a:font script="Thai" typeface="Cordia New"/>
+        <a:font script="Ethi" typeface="Nyala"/>
+        <a:font script="Beng" typeface="Vrinda"/>
+        <a:font script="Gujr" typeface="Shruti"/>
+        <a:font script="Khmr" typeface="DaunPenh"/>
+        <a:font script="Knda" typeface="Tunga"/>
+        <a:font script="Guru" typeface="Raavi"/>
+        <a:font script="Cans" typeface="Euphemia"/>
+        <a:font script="Cher" typeface="Plantagenet Cherokee"/>
+        <a:font script="Yiii" typeface="Microsoft Yi Baiti"/>
+        <a:font script="Tibt" typeface="Microsoft Himalaya"/>
+        <a:font script="Thaa" typeface="MV Boli"/>
+        <a:font script="Deva" typeface="Mangal"/>
+        <a:font script="Telu" typeface="Gautami"/>
+        <a:font script="Taml" typeface="Latha"/>
+        <a:font script="Syrc" typeface="Estrangelo Edessa"/>
+        <a:font script="Orya" typeface="Kalinga"/>
+        <a:font script="Mlym" typeface="Kartika"/>
+        <a:font script="Laoo" typeface="DokChampa"/>
+        <a:font script="Sinh" typeface="Iskoola Pota"/>
+        <a:font script="Mong" typeface="Mongolian Baiti"/>
+        <a:font script="Viet" typeface="Arial"/>
+        <a:font script="Uigh" typeface="Microsoft Uighur"/>
+        <a:font script="Geor" typeface="Sylfaen"/>
+        <a:font script="Armn" typeface="Arial"/>
+        <a:font script="Bugi" typeface="Leelawadee UI"/>
+        <a:font script="Bopo" typeface="Microsoft JhengHei"/>
+        <a:font script="Java" typeface="Javanese Text"/>
+        <a:font script="Lisu" typeface="Segoe UI"/>
+        <a:font script="Mymr" typeface="Myanmar Text"/>
+        <a:font script="Nkoo" typeface="Ebrima"/>
+        <a:font script="Olck" typeface="Nirmala UI"/>
+        <a:font script="Osma" typeface="Ebrima"/>
+        <a:font script="Phag" typeface="Phagspa"/>
+        <a:font script="Syrn" typeface="Estrangelo Edessa"/>
+        <a:font script="Syrj" typeface="Estrangelo Edessa"/>
+        <a:font script="Syre" typeface="Estrangelo Edessa"/>
+        <a:font script="Sora" typeface="Nirmala UI"/>
+        <a:font script="Tale" typeface="Microsoft Tai Le"/>
+        <a:font script="Talu" typeface="Microsoft New Tai Lue"/>
+        <a:font script="Tfng" typeface="Ebrima"/>
+      </a:minorFont>
+    </a:fontScheme>
+    <a:fmtScheme name="Office">
+      <a:fillStyleLst>
+        <a:solidFill>
+          <a:schemeClr val="phClr"/>
+        </a:solidFill>
+        <a:gradFill rotWithShape="1">
+          <a:gsLst>
+            <a:gs pos="0">
+              <a:schemeClr val="phClr">
+                <a:lumMod val="110000"/>
+                <a:satMod val="105000"/>
+                <a:tint val="67000"/>
+              </a:schemeClr>
+            </a:gs>
+            <a:gs pos="50000">
+              <a:schemeClr val="phClr">
+                <a:lumMod val="105000"/>
+                <a:satMod val="103000"/>
+                <a:tint val="73000"/>
+              </a:schemeClr>
+            </a:gs>
+            <a:gs pos="100000">
+              <a:schemeClr val="phClr">
+                <a:lumMod val="105000"/>
+                <a:satMod val="109000"/>
+                <a:tint val="81000"/>
+              </a:schemeClr>
+            </a:gs>
+          </a:gsLst>
+          <a:lin ang="5400000" scaled="0"/>
+        </a:gradFill>
+        <a:gradFill rotWithShape="1">
+          <a:gsLst>
+            <a:gs pos="0">
+              <a:schemeClr val="phClr">
+                <a:satMod val="103000"/>
+                <a:lumMod val="102000"/>
+                <a:tint val="94000"/>
+              </a:schemeClr>
+            </a:gs>
+            <a:gs pos="50000">
+              <a:schemeClr val="phClr">
+                <a:satMod val="110000"/>
+                <a:lumMod val="100000"/>
+                <a:shade val="100000"/>
+              </a:schemeClr>
+            </a:gs>
+            <a:gs pos="100000">
+              <a:schemeClr val="phClr">
+                <a:lumMod val="99000"/>
+                <a:satMod val="120000"/>
+                <a:shade val="78000"/>
+              </a:schemeClr>
+            </a:gs>
+          </a:gsLst>
+          <a:lin ang="5400000" scaled="0"/>
+        </a:gradFill>
+      </a:fillStyleLst>
+      <a:lnStyleLst>
+        <a:ln w="12700" cap="flat" cmpd="sng" algn="ctr">
+          <a:solidFill>
+            <a:schemeClr val="phClr"/>
+          </a:solidFill>
+          <a:prstDash val="solid"/>
+          <a:miter lim="800000"/>
+        </a:ln>
+        <a:ln w="19050" cap="flat" cmpd="sng" algn="ctr">
+          <a:solidFill>
+            <a:schemeClr val="phClr"/>
+          </a:solidFill>
+          <a:prstDash val="solid"/>
+          <a:miter lim="800000"/>
+        </a:ln>
+        <a:ln w="25400" cap="flat" cmpd="sng" algn="ctr">
+          <a:solidFill>
+            <a:schemeClr val="phClr"/>
+          </a:solidFill>
+          <a:prstDash val="solid"/>
+          <a:miter lim="800000"/>
+        </a:ln>
+      </a:lnStyleLst>
+      <a:effectStyleLst>
+        <a:effectStyle>
+          <a:effectLst/>
+        </a:effectStyle>
+        <a:effectStyle>
+          <a:effectLst/>
+        </a:effectStyle>
+        <a:effectStyle>
+          <a:effectLst>
+            <a:outerShdw blurRad="57150" dist="19050" dir="5400000" algn="ctr" rotWithShape="0">
+              <a:srgbClr val="000000">
+                <a:alpha val="63000"/>
+              </a:srgbClr>
+            </a:outerShdw>
+          </a:effectLst>
+        </a:effectStyle>
+      </a:effectStyleLst>
+      <a:bgFillStyleLst>
+        <a:solidFill>
+          <a:schemeClr val="phClr"/>
+        </a:solidFill>
+        <a:solidFill>
+          <a:schemeClr val="phClr">
+            <a:tint val="95000"/>
+            <a:satMod val="170000"/>
+          </a:schemeClr>
+        </a:solidFill>
+        <a:gradFill rotWithShape="1">
+          <a:gsLst>
+            <a:gs pos="0">
+              <a:schemeClr val="phClr">
+                <a:tint val="93000"/>
+                <a:satMod val="150000"/>
+                <a:shade val="98000"/>
+                <a:lumMod val="102000"/>
+              </a:schemeClr>
+            </a:gs>
+            <a:gs pos="50000">
+              <a:schemeClr val="phClr">
+                <a:tint val="98000"/>
+                <a:satMod val="130000"/>
+                <a:shade val="90000"/>
+                <a:lumMod val="103000"/>
+              </a:schemeClr>
+            </a:gs>
+            <a:gs pos="100000">
+              <a:schemeClr val="phClr">
+                <a:shade val="63000"/>
+                <a:satMod val="120000"/>
+              </a:schemeClr>
+            </a:gs>
+          </a:gsLst>
+          <a:lin ang="5400000" scaled="0"/>
+        </a:gradFill>
+      </a:bgFillStyleLst>
+    </a:fmtScheme>
+  </a:themeElements>
+  <a:objectDefaults>
+    <a:lnDef>
+      <a:spPr/>
+      <a:bodyPr/>
+      <a:lstStyle/>
+      <a:style>
+        <a:lnRef idx="2">
+          <a:schemeClr val="accent1"/>
+        </a:lnRef>
+        <a:fillRef idx="0">
+          <a:schemeClr val="accent1"/>
+        </a:fillRef>
+        <a:effectRef idx="1">
+          <a:schemeClr val="accent1"/>
+        </a:effectRef>
+        <a:fontRef idx="minor">
+          <a:schemeClr val="tx1"/>
+        </a:fontRef>
+      </a:style>
+    </a:lnDef>
+  </a:objectDefaults>
+  <a:extraClrSchemeLst/>
+  <a:extLst>
+    <a:ext uri="{05A4C25C-085E-4340-85A3-A5531E510DB2}">
+      <thm15:themeFamily xmlns:thm15="http://schemas.microsoft.com/office/thememl/2012/main" name="Office Theme" id="{2E142A2C-CD16-42D6-873A-C26D2A0506FA}" vid="{1BDDFF52-6CD6-40A5-AB3C-68EB2F1E4D0A}"/>
+    </a:ext>
+  </a:extLst>
+</a:theme>
 </file>
</xml_diff>